<commit_message>
feat: Add v2 script for generating PowerPoint presentations.
</commit_message>
<xml_diff>
--- a/docs/MBP-T05_ChildLock_결과발표.pptx
+++ b/docs/MBP-T05_ChildLock_결과발표.pptx
@@ -3283,7 +3283,7 @@
               </a:defRPr>
             </a:pPr>
             <a:r>
-              <a:t>[PBL 과목명 입력]</a:t>
+              <a:t>ISO 26262 SW 시뮬레이션 프로젝트</a:t>
             </a:r>
           </a:p>
         </p:txBody>
@@ -3318,7 +3318,7 @@
               </a:defRPr>
             </a:pPr>
             <a:r>
-              <a:t>예: PBL1 ISO26262 / PBL2 ASPICE / PBL3 SW설계 / PBL4 CANoe / PBL5 데이터분석 / PBL6 AUTOSAR</a:t>
+              <a:t>자율주행 제어 및 검증 기반</a:t>
             </a:r>
           </a:p>
         </p:txBody>
@@ -3353,7 +3353,7 @@
               </a:defRPr>
             </a:pPr>
             <a:r>
-              <a:t>[팀명]</a:t>
+              <a:t>전차</a:t>
             </a:r>
           </a:p>
         </p:txBody>
@@ -3388,7 +3388,7 @@
               </a:defRPr>
             </a:pPr>
             <a:r>
-              <a:t>[프로젝트명]</a:t>
+              <a:t>전자식 차일드 락 시스템 (MBP-T05)</a:t>
             </a:r>
           </a:p>
         </p:txBody>
@@ -3423,7 +3423,7 @@
               </a:defRPr>
             </a:pPr>
             <a:r>
-              <a:t>2026. 02. __</a:t>
+              <a:t>2026. 03. 22</a:t>
             </a:r>
           </a:p>
         </p:txBody>
@@ -4044,7 +4044,7 @@
               </a:defRPr>
             </a:pPr>
             <a:r>
-              <a:t>[팀원 1 이름]</a:t>
+              <a:t>박기준 (팀장)</a:t>
             </a:r>
           </a:p>
         </p:txBody>
@@ -4079,7 +4079,7 @@
               </a:defRPr>
             </a:pPr>
             <a:r>
-              <a:t>[역할]</a:t>
+              <a:t>프로젝트 리더 &amp; 아키텍트</a:t>
             </a:r>
           </a:p>
         </p:txBody>
@@ -4114,15 +4114,8 @@
               </a:defRPr>
             </a:pPr>
             <a:r>
-              <a:t>• 담당 업무 1</a:t>
-            </a:r>
-            <a:br/>
-            <a:r>
-              <a:t>• 담당 업무 2</a:t>
-            </a:r>
-            <a:br/>
-            <a:r>
-              <a:t>• 기술 스택</a:t>
+              <a:t>• 도어 및 하차 안전 제어 로직 기획/구현
+• 단위 테스트 및 CI 환경 구축</a:t>
             </a:r>
           </a:p>
         </p:txBody>
@@ -4247,7 +4240,7 @@
               </a:defRPr>
             </a:pPr>
             <a:r>
-              <a:t>[팀원 2 이름]</a:t>
+              <a:t>김도균 / 김이안</a:t>
             </a:r>
           </a:p>
         </p:txBody>
@@ -4282,7 +4275,7 @@
               </a:defRPr>
             </a:pPr>
             <a:r>
-              <a:t>[역할]</a:t>
+              <a:t>프로젝트 리더 &amp; 아키텍트</a:t>
             </a:r>
           </a:p>
         </p:txBody>
@@ -4317,15 +4310,8 @@
               </a:defRPr>
             </a:pPr>
             <a:r>
-              <a:t>• 담당 업무 1</a:t>
-            </a:r>
-            <a:br/>
-            <a:r>
-              <a:t>• 담당 업무 2</a:t>
-            </a:r>
-            <a:br/>
-            <a:r>
-              <a:t>• 기술 스택</a:t>
+              <a:t>• 도어 및 하차 안전 제어 로직 기획/구현
+• 단위 테스트 및 CI 환경 구축</a:t>
             </a:r>
           </a:p>
         </p:txBody>
@@ -4450,7 +4436,7 @@
               </a:defRPr>
             </a:pPr>
             <a:r>
-              <a:t>[팀원 3 이름]</a:t>
+              <a:t>이한결 / 이승욱</a:t>
             </a:r>
           </a:p>
         </p:txBody>
@@ -4485,7 +4471,7 @@
               </a:defRPr>
             </a:pPr>
             <a:r>
-              <a:t>[역할]</a:t>
+              <a:t>프로젝트 리더 &amp; 아키텍트</a:t>
             </a:r>
           </a:p>
         </p:txBody>
@@ -4520,15 +4506,8 @@
               </a:defRPr>
             </a:pPr>
             <a:r>
-              <a:t>• 담당 업무 1</a:t>
-            </a:r>
-            <a:br/>
-            <a:r>
-              <a:t>• 담당 업무 2</a:t>
-            </a:r>
-            <a:br/>
-            <a:r>
-              <a:t>• 기술 스택</a:t>
+              <a:t>• 도어 및 하차 안전 제어 로직 기획/구현
+• 단위 테스트 및 CI 환경 구축</a:t>
             </a:r>
           </a:p>
         </p:txBody>
@@ -4653,7 +4632,7 @@
               </a:defRPr>
             </a:pPr>
             <a:r>
-              <a:t>[팀원 4 이름]</a:t>
+              <a:t>박찬석</a:t>
             </a:r>
           </a:p>
         </p:txBody>
@@ -4688,7 +4667,7 @@
               </a:defRPr>
             </a:pPr>
             <a:r>
-              <a:t>[역할]</a:t>
+              <a:t>프로젝트 리더 &amp; 아키텍트</a:t>
             </a:r>
           </a:p>
         </p:txBody>
@@ -4723,15 +4702,8 @@
               </a:defRPr>
             </a:pPr>
             <a:r>
-              <a:t>• 담당 업무 1</a:t>
-            </a:r>
-            <a:br/>
-            <a:r>
-              <a:t>• 담당 업무 2</a:t>
-            </a:r>
-            <a:br/>
-            <a:r>
-              <a:t>• 기술 스택</a:t>
+              <a:t>• 도어 및 하차 안전 제어 로직 기획/구현
+• 단위 테스트 및 CI 환경 구축</a:t>
             </a:r>
           </a:p>
         </p:txBody>
@@ -4977,23 +4949,15 @@
           </a:bodyPr>
           <a:lstStyle/>
           <a:p>
+            <a:pPr algn="l">
+              <a:defRPr sz="1800" b="1">
+                <a:solidFill>
+                  <a:srgbClr val="B43C3C"/>
+                </a:solidFill>
+              </a:defRPr>
+            </a:pPr>
             <a:r>
               <a:t>AS-IS (현재 문제점)</a:t>
-            </a:r>
-          </a:p>
-          <a:p>
-            <a:r>
-              <a:t>• 문제점 1: 수동 기계식 차일드 락의 조작 불편 (운전자 직접 변경 필요)</a:t>
-            </a:r>
-          </a:p>
-          <a:p>
-            <a:r>
-              <a:t>• 문제점 2: 사고 시 뒷좌석 승객 탈출 지연 위험</a:t>
-            </a:r>
-          </a:p>
-          <a:p>
-            <a:r>
-              <a:t>• 문제점 3: 후방 위험(자전거/오토바이 등) 인지 및 제어 수단 부재</a:t>
             </a:r>
           </a:p>
         </p:txBody>
@@ -5028,17 +4992,7 @@
               </a:defRPr>
             </a:pPr>
             <a:r>
-              <a:t>• 문제점 1: [설명]</a:t>
-            </a:r>
-            <a:br/>
-            <a:br/>
-            <a:r>
-              <a:t>• 문제점 2: [설명]</a:t>
-            </a:r>
-            <a:br/>
-            <a:br/>
-            <a:r>
-              <a:t>• 문제점 3: [설명]</a:t>
+              <a:t>문제점 1: 기계식 차일드 락의 운전자 직접 제어 불편함</a:t>
             </a:r>
           </a:p>
         </p:txBody>
@@ -5153,23 +5107,15 @@
           </a:bodyPr>
           <a:lstStyle/>
           <a:p>
+            <a:pPr algn="l">
+              <a:defRPr sz="1800" b="1">
+                <a:solidFill>
+                  <a:srgbClr val="3C8C3C"/>
+                </a:solidFill>
+              </a:defRPr>
+            </a:pPr>
             <a:r>
               <a:t>TO-BE (목표 상태)</a:t>
-            </a:r>
-          </a:p>
-          <a:p>
-            <a:r>
-              <a:t>• 목표 1: 속도 기반 자동 잠금 제어를 통한 편의 개선</a:t>
-            </a:r>
-          </a:p>
-          <a:p>
-            <a:r>
-              <a:t>• 목표 2: 충돌 등 비상 상황 시 뒷좌석 자동 잠금 해제로 대피 지원</a:t>
-            </a:r>
-          </a:p>
-          <a:p>
-            <a:r>
-              <a:t>• 목표 3: 후방 센서 연동을 통한 하차 시 보호 로직 탑재</a:t>
             </a:r>
           </a:p>
         </p:txBody>
@@ -5204,17 +5150,7 @@
               </a:defRPr>
             </a:pPr>
             <a:r>
-              <a:t>• 목표 1: [설명]</a:t>
-            </a:r>
-            <a:br/>
-            <a:br/>
-            <a:r>
-              <a:t>• 목표 2: [설명]</a:t>
-            </a:r>
-            <a:br/>
-            <a:br/>
-            <a:r>
-              <a:t>• 목표 3: [설명]</a:t>
+              <a:t>목표 1: 속도 기반 자동 잠금으로 편의성 개선</a:t>
             </a:r>
           </a:p>
         </p:txBody>
@@ -5286,13 +5222,15 @@
           </a:bodyPr>
           <a:lstStyle/>
           <a:p>
+            <a:pPr algn="l">
+              <a:defRPr sz="1600" b="1">
+                <a:solidFill>
+                  <a:srgbClr val="003366"/>
+                </a:solidFill>
+              </a:defRPr>
+            </a:pPr>
             <a:r>
               <a:t>핵심 연구 질문</a:t>
-            </a:r>
-          </a:p>
-          <a:p>
-            <a:r>
-              <a:t>ISO 26262 안전 표준을 준수하면서 승객의 편의성과 하차 안전을 모두 만족하는 지능형 차일드 락 SW를 어떻게 구현할 것인가?</a:t>
             </a:r>
           </a:p>
         </p:txBody>
@@ -5327,12 +5265,7 @@
               </a:defRPr>
             </a:pPr>
             <a:r>
-              <a:t>[이 프로젝트를 통해 해결하고자 하는 핵심 질문을 작성하세요]</a:t>
-            </a:r>
-            <a:br/>
-            <a:br/>
-            <a:r>
-              <a:t>예: "차량 주행 데이터를 분석하여 운전자의 위험 운전 패턴을 사전에 감지할 수 있는가?"</a:t>
+              <a:t>ISO 26262를 준수하면서 승객의 편의성과 하차 안전을 모두 만족하는 지능형 차일드 락 제어기를 어떻게 구현할 것인가?</a:t>
             </a:r>
           </a:p>
         </p:txBody>
@@ -5576,8 +5509,15 @@
           </a:bodyPr>
           <a:lstStyle/>
           <a:p>
-            <a:r>
-              <a:t>지능형 센서 및 차량 속도 연동 안전 제어 소프트웨어</a:t>
+            <a:pPr algn="ctr">
+              <a:defRPr sz="2200" b="1">
+                <a:solidFill>
+                  <a:srgbClr val="FFFFFF"/>
+                </a:solidFill>
+              </a:defRPr>
+            </a:pPr>
+            <a:r>
+              <a:t>지능형 센서 및 차량 상태 연동 제어 기반의 통합 하차 안전 솔루션 (FG-01 / FG-02)</a:t>
             </a:r>
           </a:p>
         </p:txBody>
@@ -5612,7 +5552,7 @@
               </a:defRPr>
             </a:pPr>
             <a:r>
-              <a:t>예: CAN 데이터 기반 실시간 이상 탐지 시스템</a:t>
+              <a:t>C/C++ 기반 ISO 26262 안전 요구사항 적용 제어 로직 모듈 탑재</a:t>
             </a:r>
           </a:p>
         </p:txBody>
@@ -5762,18 +5702,15 @@
           </a:bodyPr>
           <a:lstStyle/>
           <a:p>
-            <a:r>
-              <a:t>FG-01 도어 잠금/해제 제어</a:t>
-            </a:r>
-          </a:p>
-          <a:p>
-            <a:r>
-              <a:t>• 운전자 스위치 조작 제어</a:t>
-            </a:r>
-          </a:p>
-          <a:p>
-            <a:r>
-              <a:t>• 차량 속도 연동 자동 잠금 활성화</a:t>
+            <a:pPr algn="ctr">
+              <a:defRPr sz="1600" b="1">
+                <a:solidFill>
+                  <a:srgbClr val="333333"/>
+                </a:solidFill>
+              </a:defRPr>
+            </a:pPr>
+            <a:r>
+              <a:t>FG-01: 도어 잠금 및 해제 제어</a:t>
             </a:r>
           </a:p>
         </p:txBody>
@@ -5808,20 +5745,7 @@
               </a:defRPr>
             </a:pPr>
             <a:r>
-              <a:t>기능에 대한 상세 설명을</a:t>
-            </a:r>
-            <a:br/>
-            <a:r>
-              <a:t>이곳에 작성합니다.</a:t>
-            </a:r>
-            <a:br/>
-            <a:br/>
-            <a:r>
-              <a:t>• 세부사항 1</a:t>
-            </a:r>
-            <a:br/>
-            <a:r>
-              <a:t>• 세부사항 2</a:t>
+              <a:t>속도 센서 연동, 후측방 레이더 결합 제어 로직 (C++ State Machine)</a:t>
             </a:r>
           </a:p>
         </p:txBody>
@@ -5971,18 +5895,15 @@
           </a:bodyPr>
           <a:lstStyle/>
           <a:p>
-            <a:r>
-              <a:t>비상 상황 대처</a:t>
-            </a:r>
-          </a:p>
-          <a:p>
-            <a:r>
-              <a:t>• 차량 충돌 발생 시 뒷좌석 비상 잠금 해제 제어</a:t>
-            </a:r>
-          </a:p>
-          <a:p>
-            <a:r>
-              <a:t>• 상시 실내 탑승자 개방 금지 메커니즘 결합</a:t>
+            <a:pPr algn="ctr">
+              <a:defRPr sz="1600" b="1">
+                <a:solidFill>
+                  <a:srgbClr val="333333"/>
+                </a:solidFill>
+              </a:defRPr>
+            </a:pPr>
+            <a:r>
+              <a:t>FG-02: 하차 안전 보조 제어</a:t>
             </a:r>
           </a:p>
         </p:txBody>
@@ -6017,20 +5938,7 @@
               </a:defRPr>
             </a:pPr>
             <a:r>
-              <a:t>기능에 대한 상세 설명을</a:t>
-            </a:r>
-            <a:br/>
-            <a:r>
-              <a:t>이곳에 작성합니다.</a:t>
-            </a:r>
-            <a:br/>
-            <a:br/>
-            <a:r>
-              <a:t>• 세부사항 1</a:t>
-            </a:r>
-            <a:br/>
-            <a:r>
-              <a:t>• 세부사항 2</a:t>
+              <a:t>속도 센서 연동, 후측방 레이더 결합 제어 로직 (C++ State Machine)</a:t>
             </a:r>
           </a:p>
         </p:txBody>
@@ -6180,18 +6088,15 @@
           </a:bodyPr>
           <a:lstStyle/>
           <a:p>
-            <a:r>
-              <a:t>FG-02 하차 안전 보조 제어</a:t>
-            </a:r>
-          </a:p>
-          <a:p>
-            <a:r>
-              <a:t>• 후측방 차량/이륜차 접근 감지 연동</a:t>
-            </a:r>
-          </a:p>
-          <a:p>
-            <a:r>
-              <a:t>• 뒷좌석 점유 및 상태 요약 알림</a:t>
+            <a:pPr algn="ctr">
+              <a:defRPr sz="1600" b="1">
+                <a:solidFill>
+                  <a:srgbClr val="333333"/>
+                </a:solidFill>
+              </a:defRPr>
+            </a:pPr>
+            <a:r>
+              <a:t>Fail-Safe 설계 및 테스트 결함 주입 (Fault Injection) 방어</a:t>
             </a:r>
           </a:p>
         </p:txBody>
@@ -6226,20 +6131,7 @@
               </a:defRPr>
             </a:pPr>
             <a:r>
-              <a:t>기능에 대한 상세 설명을</a:t>
-            </a:r>
-            <a:br/>
-            <a:r>
-              <a:t>이곳에 작성합니다.</a:t>
-            </a:r>
-            <a:br/>
-            <a:br/>
-            <a:r>
-              <a:t>• 세부사항 1</a:t>
-            </a:r>
-            <a:br/>
-            <a:r>
-              <a:t>• 세부사항 2</a:t>
+              <a:t>속도 센서 연동, 후측방 레이더 결합 제어 로직 (C++ State Machine)</a:t>
             </a:r>
           </a:p>
         </p:txBody>
@@ -6465,79 +6357,6 @@
       </p:sp>
       <p:sp>
         <p:nvSpPr>
-          <p:cNvPr id="6" name="TextBox 5"/>
-          <p:cNvSpPr txBox="1"/>
-          <p:nvPr/>
-        </p:nvSpPr>
-        <p:spPr>
-          <a:xfrm>
-            <a:off x="640080" y="3200400"/>
-            <a:ext cx="7315200" cy="457200"/>
-          </a:xfrm>
-          <a:prstGeom prst="rect">
-            <a:avLst/>
-          </a:prstGeom>
-          <a:noFill/>
-        </p:spPr>
-        <p:txBody>
-          <a:bodyPr wrap="square">
-            <a:spAutoFit/>
-          </a:bodyPr>
-          <a:lstStyle/>
-          <a:p>
-            <a:r>
-              <a:t>[시스템 아키텍처 다이어그램 공간]</a:t>
-            </a:r>
-          </a:p>
-          <a:p>
-            <a:r>
-              <a:t>• State Machine: Locked, Unlocked, Emergency 상태 전이</a:t>
-            </a:r>
-          </a:p>
-          <a:p>
-            <a:r>
-              <a:t>• Logic Flow: 센서 입력 -&gt; 제어 판별 -&gt; Actuator 제어</a:t>
-            </a:r>
-          </a:p>
-        </p:txBody>
-      </p:sp>
-      <p:sp>
-        <p:nvSpPr>
-          <p:cNvPr id="7" name="TextBox 6"/>
-          <p:cNvSpPr txBox="1"/>
-          <p:nvPr/>
-        </p:nvSpPr>
-        <p:spPr>
-          <a:xfrm>
-            <a:off x="640080" y="3749039"/>
-            <a:ext cx="7315200" cy="274320"/>
-          </a:xfrm>
-          <a:prstGeom prst="rect">
-            <a:avLst/>
-          </a:prstGeom>
-          <a:noFill/>
-        </p:spPr>
-        <p:txBody>
-          <a:bodyPr wrap="square">
-            <a:spAutoFit/>
-          </a:bodyPr>
-          <a:lstStyle/>
-          <a:p>
-            <a:pPr algn="ctr">
-              <a:defRPr sz="1100" b="0">
-                <a:solidFill>
-                  <a:srgbClr val="808080"/>
-                </a:solidFill>
-              </a:defRPr>
-            </a:pPr>
-            <a:r>
-              <a:t>이미지를 삽입하거나 도형으로 구성하세요</a:t>
-            </a:r>
-          </a:p>
-        </p:txBody>
-      </p:sp>
-      <p:sp>
-        <p:nvSpPr>
           <p:cNvPr id="8" name="Rounded Rectangle 7"/>
           <p:cNvSpPr/>
           <p:nvPr/>
@@ -6601,58 +6420,15 @@
           </a:bodyPr>
           <a:lstStyle/>
           <a:p>
+            <a:pPr algn="ctr">
+              <a:defRPr sz="1600" b="1">
+                <a:solidFill>
+                  <a:srgbClr val="FFFFFF"/>
+                </a:solidFill>
+              </a:defRPr>
+            </a:pPr>
             <a:r>
               <a:t>Tech Stack</a:t>
-            </a:r>
-          </a:p>
-          <a:p>
-            <a:r>
-              <a:t>Language</a:t>
-            </a:r>
-          </a:p>
-          <a:p>
-            <a:r>
-              <a:t>C11 / C++17</a:t>
-            </a:r>
-          </a:p>
-          <a:p>
-            <a:r>
-              <a:t>Framework</a:t>
-            </a:r>
-          </a:p>
-          <a:p>
-            <a:r>
-              <a:t>ISO 26262, MISRA C:2012, ASPICE</a:t>
-            </a:r>
-          </a:p>
-          <a:p>
-            <a:r>
-              <a:t>Testing</a:t>
-            </a:r>
-          </a:p>
-          <a:p>
-            <a:r>
-              <a:t>Google Test v1.17.0, Cppcheck</a:t>
-            </a:r>
-          </a:p>
-          <a:p>
-            <a:r>
-              <a:t>Tools</a:t>
-            </a:r>
-          </a:p>
-          <a:p>
-            <a:r>
-              <a:t>CMake, Lizard, Gcov / Lcov</a:t>
-            </a:r>
-          </a:p>
-          <a:p>
-            <a:r>
-              <a:t>OS</a:t>
-            </a:r>
-          </a:p>
-          <a:p>
-            <a:r>
-              <a:t>Ubuntu 22.04 LTS</a:t>
             </a:r>
           </a:p>
         </p:txBody>
@@ -6722,7 +6498,7 @@
               </a:defRPr>
             </a:pPr>
             <a:r>
-              <a:t>[Python, C, etc.]</a:t>
+              <a:t>C11, C++17</a:t>
             </a:r>
           </a:p>
         </p:txBody>
@@ -6792,7 +6568,7 @@
               </a:defRPr>
             </a:pPr>
             <a:r>
-              <a:t>[CANoe, AUTOSAR, etc.]</a:t>
+              <a:t>ISO 26262, MISRA C:2012, ASPICE, CMake</a:t>
             </a:r>
           </a:p>
         </p:txBody>
@@ -6827,7 +6603,7 @@
               </a:defRPr>
             </a:pPr>
             <a:r>
-              <a:t>Database</a:t>
+              <a:t>Testing</a:t>
             </a:r>
           </a:p>
         </p:txBody>
@@ -6862,7 +6638,7 @@
               </a:defRPr>
             </a:pPr>
             <a:r>
-              <a:t>[MySQL, etc.]</a:t>
+              <a:t>Google Test v1.17.0, Cppcheck</a:t>
             </a:r>
           </a:p>
         </p:txBody>
@@ -6932,7 +6708,7 @@
               </a:defRPr>
             </a:pPr>
             <a:r>
-              <a:t>[Git, JIRA, etc.]</a:t>
+              <a:t>Git, GitHub Actions (CI), Gcov/Lcov</a:t>
             </a:r>
           </a:p>
         </p:txBody>
@@ -6967,7 +6743,7 @@
               </a:defRPr>
             </a:pPr>
             <a:r>
-              <a:t>Hardware</a:t>
+              <a:t>Environment</a:t>
             </a:r>
           </a:p>
         </p:txBody>
@@ -7002,7 +6778,7 @@
               </a:defRPr>
             </a:pPr>
             <a:r>
-              <a:t>[CAN 장비, etc.]</a:t>
+              <a:t>Ubuntu 22.04 LTS</a:t>
             </a:r>
           </a:p>
         </p:txBody>
@@ -7042,6 +6818,54 @@
           </a:p>
         </p:txBody>
       </p:sp>
+      <p:pic>
+        <p:nvPicPr>
+          <p:cNvPr id="21" name="Picture 20" descr="childlock_state.png"/>
+          <p:cNvPicPr>
+            <a:picLocks noChangeAspect="1"/>
+          </p:cNvPicPr>
+          <p:nvPr/>
+        </p:nvPicPr>
+        <p:blipFill>
+          <a:blip r:embed="rId2"/>
+          <a:stretch>
+            <a:fillRect/>
+          </a:stretch>
+        </p:blipFill>
+        <p:spPr>
+          <a:xfrm>
+            <a:off x="640080" y="3200400"/>
+            <a:ext cx="784531" cy="457200"/>
+          </a:xfrm>
+          <a:prstGeom prst="rect">
+            <a:avLst/>
+          </a:prstGeom>
+        </p:spPr>
+      </p:pic>
+      <p:pic>
+        <p:nvPicPr>
+          <p:cNvPr id="22" name="Picture 21" descr="childlock_state.png"/>
+          <p:cNvPicPr>
+            <a:picLocks noChangeAspect="1"/>
+          </p:cNvPicPr>
+          <p:nvPr/>
+        </p:nvPicPr>
+        <p:blipFill>
+          <a:blip r:embed="rId2"/>
+          <a:stretch>
+            <a:fillRect/>
+          </a:stretch>
+        </p:blipFill>
+        <p:spPr>
+          <a:xfrm>
+            <a:off x="640080" y="3749039"/>
+            <a:ext cx="470719" cy="274320"/>
+          </a:xfrm>
+          <a:prstGeom prst="rect">
+            <a:avLst/>
+          </a:prstGeom>
+        </p:spPr>
+      </p:pic>
     </p:spTree>
   </p:cSld>
   <p:clrMapOvr>
@@ -7228,76 +7052,6 @@
       </p:sp>
       <p:sp>
         <p:nvSpPr>
-          <p:cNvPr id="6" name="TextBox 5"/>
-          <p:cNvSpPr txBox="1"/>
-          <p:nvPr/>
-        </p:nvSpPr>
-        <p:spPr>
-          <a:xfrm>
-            <a:off x="640080" y="2103120"/>
-            <a:ext cx="4937760" cy="365760"/>
-          </a:xfrm>
-          <a:prstGeom prst="rect">
-            <a:avLst/>
-          </a:prstGeom>
-          <a:noFill/>
-        </p:spPr>
-        <p:txBody>
-          <a:bodyPr wrap="square">
-            <a:spAutoFit/>
-          </a:bodyPr>
-          <a:lstStyle/>
-          <a:p>
-            <a:pPr algn="ctr">
-              <a:defRPr sz="1400" b="0">
-                <a:solidFill>
-                  <a:srgbClr val="808080"/>
-                </a:solidFill>
-              </a:defRPr>
-            </a:pPr>
-            <a:r>
-              <a:t>[스크린샷 삽입]</a:t>
-            </a:r>
-          </a:p>
-        </p:txBody>
-      </p:sp>
-      <p:sp>
-        <p:nvSpPr>
-          <p:cNvPr id="7" name="TextBox 6"/>
-          <p:cNvSpPr txBox="1"/>
-          <p:nvPr/>
-        </p:nvSpPr>
-        <p:spPr>
-          <a:xfrm>
-            <a:off x="640080" y="3108960"/>
-            <a:ext cx="4937760" cy="274320"/>
-          </a:xfrm>
-          <a:prstGeom prst="rect">
-            <a:avLst/>
-          </a:prstGeom>
-          <a:noFill/>
-        </p:spPr>
-        <p:txBody>
-          <a:bodyPr wrap="square">
-            <a:spAutoFit/>
-          </a:bodyPr>
-          <a:lstStyle/>
-          <a:p>
-            <a:pPr algn="ctr">
-              <a:defRPr sz="1100" b="1">
-                <a:solidFill>
-                  <a:srgbClr val="003366"/>
-                </a:solidFill>
-              </a:defRPr>
-            </a:pPr>
-            <a:r>
-              <a:t>화면 1: [기능명]</a:t>
-            </a:r>
-          </a:p>
-        </p:txBody>
-      </p:sp>
-      <p:sp>
-        <p:nvSpPr>
           <p:cNvPr id="8" name="Rounded Rectangle 7"/>
           <p:cNvSpPr/>
           <p:nvPr/>
@@ -7343,76 +7097,6 @@
       </p:sp>
       <p:sp>
         <p:nvSpPr>
-          <p:cNvPr id="9" name="TextBox 8"/>
-          <p:cNvSpPr txBox="1"/>
-          <p:nvPr/>
-        </p:nvSpPr>
-        <p:spPr>
-          <a:xfrm>
-            <a:off x="6217920" y="2103120"/>
-            <a:ext cx="4937760" cy="365760"/>
-          </a:xfrm>
-          <a:prstGeom prst="rect">
-            <a:avLst/>
-          </a:prstGeom>
-          <a:noFill/>
-        </p:spPr>
-        <p:txBody>
-          <a:bodyPr wrap="square">
-            <a:spAutoFit/>
-          </a:bodyPr>
-          <a:lstStyle/>
-          <a:p>
-            <a:pPr algn="ctr">
-              <a:defRPr sz="1400" b="0">
-                <a:solidFill>
-                  <a:srgbClr val="808080"/>
-                </a:solidFill>
-              </a:defRPr>
-            </a:pPr>
-            <a:r>
-              <a:t>[스크린샷 삽입]</a:t>
-            </a:r>
-          </a:p>
-        </p:txBody>
-      </p:sp>
-      <p:sp>
-        <p:nvSpPr>
-          <p:cNvPr id="10" name="TextBox 9"/>
-          <p:cNvSpPr txBox="1"/>
-          <p:nvPr/>
-        </p:nvSpPr>
-        <p:spPr>
-          <a:xfrm>
-            <a:off x="6217920" y="3108960"/>
-            <a:ext cx="4937760" cy="274320"/>
-          </a:xfrm>
-          <a:prstGeom prst="rect">
-            <a:avLst/>
-          </a:prstGeom>
-          <a:noFill/>
-        </p:spPr>
-        <p:txBody>
-          <a:bodyPr wrap="square">
-            <a:spAutoFit/>
-          </a:bodyPr>
-          <a:lstStyle/>
-          <a:p>
-            <a:pPr algn="ctr">
-              <a:defRPr sz="1100" b="1">
-                <a:solidFill>
-                  <a:srgbClr val="003366"/>
-                </a:solidFill>
-              </a:defRPr>
-            </a:pPr>
-            <a:r>
-              <a:t>화면 2: [기능명]</a:t>
-            </a:r>
-          </a:p>
-        </p:txBody>
-      </p:sp>
-      <p:sp>
-        <p:nvSpPr>
           <p:cNvPr id="11" name="Rounded Rectangle 10"/>
           <p:cNvSpPr/>
           <p:nvPr/>
@@ -7458,76 +7142,6 @@
       </p:sp>
       <p:sp>
         <p:nvSpPr>
-          <p:cNvPr id="12" name="TextBox 11"/>
-          <p:cNvSpPr txBox="1"/>
-          <p:nvPr/>
-        </p:nvSpPr>
-        <p:spPr>
-          <a:xfrm>
-            <a:off x="640080" y="4572000"/>
-            <a:ext cx="4937760" cy="365760"/>
-          </a:xfrm>
-          <a:prstGeom prst="rect">
-            <a:avLst/>
-          </a:prstGeom>
-          <a:noFill/>
-        </p:spPr>
-        <p:txBody>
-          <a:bodyPr wrap="square">
-            <a:spAutoFit/>
-          </a:bodyPr>
-          <a:lstStyle/>
-          <a:p>
-            <a:pPr algn="ctr">
-              <a:defRPr sz="1400" b="0">
-                <a:solidFill>
-                  <a:srgbClr val="808080"/>
-                </a:solidFill>
-              </a:defRPr>
-            </a:pPr>
-            <a:r>
-              <a:t>[스크린샷 삽입]</a:t>
-            </a:r>
-          </a:p>
-        </p:txBody>
-      </p:sp>
-      <p:sp>
-        <p:nvSpPr>
-          <p:cNvPr id="13" name="TextBox 12"/>
-          <p:cNvSpPr txBox="1"/>
-          <p:nvPr/>
-        </p:nvSpPr>
-        <p:spPr>
-          <a:xfrm>
-            <a:off x="640080" y="5577840"/>
-            <a:ext cx="4937760" cy="274320"/>
-          </a:xfrm>
-          <a:prstGeom prst="rect">
-            <a:avLst/>
-          </a:prstGeom>
-          <a:noFill/>
-        </p:spPr>
-        <p:txBody>
-          <a:bodyPr wrap="square">
-            <a:spAutoFit/>
-          </a:bodyPr>
-          <a:lstStyle/>
-          <a:p>
-            <a:pPr algn="ctr">
-              <a:defRPr sz="1100" b="1">
-                <a:solidFill>
-                  <a:srgbClr val="003366"/>
-                </a:solidFill>
-              </a:defRPr>
-            </a:pPr>
-            <a:r>
-              <a:t>화면 3: [기능명]</a:t>
-            </a:r>
-          </a:p>
-        </p:txBody>
-      </p:sp>
-      <p:sp>
-        <p:nvSpPr>
           <p:cNvPr id="14" name="Rounded Rectangle 13"/>
           <p:cNvSpPr/>
           <p:nvPr/>
@@ -7573,76 +7187,6 @@
       </p:sp>
       <p:sp>
         <p:nvSpPr>
-          <p:cNvPr id="15" name="TextBox 14"/>
-          <p:cNvSpPr txBox="1"/>
-          <p:nvPr/>
-        </p:nvSpPr>
-        <p:spPr>
-          <a:xfrm>
-            <a:off x="6217920" y="4572000"/>
-            <a:ext cx="4937760" cy="365760"/>
-          </a:xfrm>
-          <a:prstGeom prst="rect">
-            <a:avLst/>
-          </a:prstGeom>
-          <a:noFill/>
-        </p:spPr>
-        <p:txBody>
-          <a:bodyPr wrap="square">
-            <a:spAutoFit/>
-          </a:bodyPr>
-          <a:lstStyle/>
-          <a:p>
-            <a:pPr algn="ctr">
-              <a:defRPr sz="1400" b="0">
-                <a:solidFill>
-                  <a:srgbClr val="808080"/>
-                </a:solidFill>
-              </a:defRPr>
-            </a:pPr>
-            <a:r>
-              <a:t>[스크린샷 삽입]</a:t>
-            </a:r>
-          </a:p>
-        </p:txBody>
-      </p:sp>
-      <p:sp>
-        <p:nvSpPr>
-          <p:cNvPr id="16" name="TextBox 15"/>
-          <p:cNvSpPr txBox="1"/>
-          <p:nvPr/>
-        </p:nvSpPr>
-        <p:spPr>
-          <a:xfrm>
-            <a:off x="6217920" y="5577840"/>
-            <a:ext cx="4937760" cy="274320"/>
-          </a:xfrm>
-          <a:prstGeom prst="rect">
-            <a:avLst/>
-          </a:prstGeom>
-          <a:noFill/>
-        </p:spPr>
-        <p:txBody>
-          <a:bodyPr wrap="square">
-            <a:spAutoFit/>
-          </a:bodyPr>
-          <a:lstStyle/>
-          <a:p>
-            <a:pPr algn="ctr">
-              <a:defRPr sz="1100" b="1">
-                <a:solidFill>
-                  <a:srgbClr val="003366"/>
-                </a:solidFill>
-              </a:defRPr>
-            </a:pPr>
-            <a:r>
-              <a:t>화면 4: [기능명]</a:t>
-            </a:r>
-          </a:p>
-        </p:txBody>
-      </p:sp>
-      <p:sp>
-        <p:nvSpPr>
           <p:cNvPr id="17" name="TextBox 16"/>
           <p:cNvSpPr txBox="1"/>
           <p:nvPr/>
@@ -7676,6 +7220,102 @@
           </a:p>
         </p:txBody>
       </p:sp>
+      <p:pic>
+        <p:nvPicPr>
+          <p:cNvPr id="18" name="Picture 17" descr="usecase_normal.png"/>
+          <p:cNvPicPr>
+            <a:picLocks noChangeAspect="1"/>
+          </p:cNvPicPr>
+          <p:nvPr/>
+        </p:nvPicPr>
+        <p:blipFill>
+          <a:blip r:embed="rId2"/>
+          <a:stretch>
+            <a:fillRect/>
+          </a:stretch>
+        </p:blipFill>
+        <p:spPr>
+          <a:xfrm>
+            <a:off x="640080" y="2103120"/>
+            <a:ext cx="4937760" cy="5448563"/>
+          </a:xfrm>
+          <a:prstGeom prst="rect">
+            <a:avLst/>
+          </a:prstGeom>
+        </p:spPr>
+      </p:pic>
+      <p:pic>
+        <p:nvPicPr>
+          <p:cNvPr id="19" name="Picture 18" descr="usecase_emergency.png"/>
+          <p:cNvPicPr>
+            <a:picLocks noChangeAspect="1"/>
+          </p:cNvPicPr>
+          <p:nvPr/>
+        </p:nvPicPr>
+        <p:blipFill>
+          <a:blip r:embed="rId3"/>
+          <a:stretch>
+            <a:fillRect/>
+          </a:stretch>
+        </p:blipFill>
+        <p:spPr>
+          <a:xfrm>
+            <a:off x="6217920" y="2103120"/>
+            <a:ext cx="4937760" cy="3325568"/>
+          </a:xfrm>
+          <a:prstGeom prst="rect">
+            <a:avLst/>
+          </a:prstGeom>
+        </p:spPr>
+      </p:pic>
+      <p:pic>
+        <p:nvPicPr>
+          <p:cNvPr id="20" name="Picture 19" descr="FG-01_door_control.png"/>
+          <p:cNvPicPr>
+            <a:picLocks noChangeAspect="1"/>
+          </p:cNvPicPr>
+          <p:nvPr/>
+        </p:nvPicPr>
+        <p:blipFill>
+          <a:blip r:embed="rId4"/>
+          <a:stretch>
+            <a:fillRect/>
+          </a:stretch>
+        </p:blipFill>
+        <p:spPr>
+          <a:xfrm>
+            <a:off x="640080" y="4572000"/>
+            <a:ext cx="4937760" cy="2737045"/>
+          </a:xfrm>
+          <a:prstGeom prst="rect">
+            <a:avLst/>
+          </a:prstGeom>
+        </p:spPr>
+      </p:pic>
+      <p:pic>
+        <p:nvPicPr>
+          <p:cNvPr id="21" name="Picture 20" descr="FG-02_exit_safety.png"/>
+          <p:cNvPicPr>
+            <a:picLocks noChangeAspect="1"/>
+          </p:cNvPicPr>
+          <p:nvPr/>
+        </p:nvPicPr>
+        <p:blipFill>
+          <a:blip r:embed="rId5"/>
+          <a:stretch>
+            <a:fillRect/>
+          </a:stretch>
+        </p:blipFill>
+        <p:spPr>
+          <a:xfrm>
+            <a:off x="6217920" y="4572000"/>
+            <a:ext cx="4937760" cy="1783826"/>
+          </a:xfrm>
+          <a:prstGeom prst="rect">
+            <a:avLst/>
+          </a:prstGeom>
+        </p:spPr>
+      </p:pic>
     </p:spTree>
   </p:cSld>
   <p:clrMapOvr>
@@ -7882,18 +7522,15 @@
           </a:bodyPr>
           <a:lstStyle/>
           <a:p>
-            <a:r>
-              <a:t>테스트 케이스 및 결과 (단위 및 서브시스템 검증)</a:t>
-            </a:r>
-          </a:p>
-          <a:p>
-            <a:r>
-              <a:t>• UC-01~07 전 구간 GTest 기반 테스트 작성</a:t>
-            </a:r>
-          </a:p>
-          <a:p>
-            <a:r>
-              <a:t>• 상태 머신 (State Machine) 전이 조건 만족 검증</a:t>
+            <a:pPr algn="l">
+              <a:defRPr sz="1600" b="1">
+                <a:solidFill>
+                  <a:srgbClr val="003366"/>
+                </a:solidFill>
+              </a:defRPr>
+            </a:pPr>
+            <a:r>
+              <a:t>테스트 케이스 및 결과</a:t>
             </a:r>
           </a:p>
         </p:txBody>
@@ -7971,7 +7608,7 @@
               </a:defRPr>
             </a:pPr>
             <a:r>
-              <a:t>테스트 항목</a:t>
+              <a:t>테스트 항목 (TC-CHL-001 ~ 015 &amp; GTest Suites)</a:t>
             </a:r>
           </a:p>
         </p:txBody>
@@ -8049,7 +7686,7 @@
               </a:defRPr>
             </a:pPr>
             <a:r>
-              <a:t>예상 결과</a:t>
+              <a:t>ASIL B / QM 검증 요구사항</a:t>
             </a:r>
           </a:p>
         </p:txBody>
@@ -8127,7 +7764,7 @@
               </a:defRPr>
             </a:pPr>
             <a:r>
-              <a:t>실제 결과</a:t>
+              <a:t>테스트 커버리지 달성 결과</a:t>
             </a:r>
           </a:p>
         </p:txBody>
@@ -8285,7 +7922,7 @@
               </a:defRPr>
             </a:pPr>
             <a:r>
-              <a:t>[입력]</a:t>
+              <a:t>정상 동작 검증 (Pass)</a:t>
             </a:r>
           </a:p>
         </p:txBody>
@@ -8365,7 +8002,7 @@
               </a:defRPr>
             </a:pPr>
             <a:r>
-              <a:t>[입력]</a:t>
+              <a:t>정상 동작 검증 (Pass)</a:t>
             </a:r>
           </a:p>
         </p:txBody>
@@ -8445,7 +8082,7 @@
               </a:defRPr>
             </a:pPr>
             <a:r>
-              <a:t>[입력]</a:t>
+              <a:t>정상 동작 검증 (Pass)</a:t>
             </a:r>
           </a:p>
         </p:txBody>
@@ -8525,7 +8162,7 @@
               </a:defRPr>
             </a:pPr>
             <a:r>
-              <a:t>[입력]</a:t>
+              <a:t>정상 동작 검증 (Pass)</a:t>
             </a:r>
           </a:p>
         </p:txBody>
@@ -8605,7 +8242,7 @@
               </a:defRPr>
             </a:pPr>
             <a:r>
-              <a:t>[입력]</a:t>
+              <a:t>정상 동작 검증 (Pass)</a:t>
             </a:r>
           </a:p>
         </p:txBody>
@@ -8685,7 +8322,7 @@
               </a:defRPr>
             </a:pPr>
             <a:r>
-              <a:t>[입력]</a:t>
+              <a:t>정상 동작 검증 (Pass)</a:t>
             </a:r>
           </a:p>
         </p:txBody>
@@ -8765,7 +8402,7 @@
               </a:defRPr>
             </a:pPr>
             <a:r>
-              <a:t>[입력]</a:t>
+              <a:t>정상 동작 검증 (Pass)</a:t>
             </a:r>
           </a:p>
         </p:txBody>
@@ -8845,7 +8482,7 @@
               </a:defRPr>
             </a:pPr>
             <a:r>
-              <a:t>[입력]</a:t>
+              <a:t>정상 동작 검증 (Pass)</a:t>
             </a:r>
           </a:p>
         </p:txBody>
@@ -8925,7 +8562,7 @@
               </a:defRPr>
             </a:pPr>
             <a:r>
-              <a:t>[입력]</a:t>
+              <a:t>정상 동작 검증 (Pass)</a:t>
             </a:r>
           </a:p>
         </p:txBody>
@@ -9005,7 +8642,7 @@
               </a:defRPr>
             </a:pPr>
             <a:r>
-              <a:t>[입력]</a:t>
+              <a:t>정상 동작 검증 (Pass)</a:t>
             </a:r>
           </a:p>
         </p:txBody>
@@ -9085,7 +8722,7 @@
               </a:defRPr>
             </a:pPr>
             <a:r>
-              <a:t>[입력]</a:t>
+              <a:t>정상 동작 검증 (Pass)</a:t>
             </a:r>
           </a:p>
         </p:txBody>
@@ -9165,7 +8802,7 @@
               </a:defRPr>
             </a:pPr>
             <a:r>
-              <a:t>[입력]</a:t>
+              <a:t>정상 동작 검증 (Pass)</a:t>
             </a:r>
           </a:p>
         </p:txBody>
@@ -9245,7 +8882,7 @@
               </a:defRPr>
             </a:pPr>
             <a:r>
-              <a:t>[입력]</a:t>
+              <a:t>정상 동작 검증 (Pass)</a:t>
             </a:r>
           </a:p>
         </p:txBody>
@@ -9325,7 +8962,7 @@
               </a:defRPr>
             </a:pPr>
             <a:r>
-              <a:t>[입력]</a:t>
+              <a:t>정상 동작 검증 (Pass)</a:t>
             </a:r>
           </a:p>
         </p:txBody>
@@ -9405,7 +9042,7 @@
               </a:defRPr>
             </a:pPr>
             <a:r>
-              <a:t>[입력]</a:t>
+              <a:t>정상 동작 검증 (Pass)</a:t>
             </a:r>
           </a:p>
         </p:txBody>
@@ -9485,7 +9122,7 @@
               </a:defRPr>
             </a:pPr>
             <a:r>
-              <a:t>[입력]</a:t>
+              <a:t>정상 동작 검증 (Pass)</a:t>
             </a:r>
           </a:p>
         </p:txBody>
@@ -9565,7 +9202,7 @@
               </a:defRPr>
             </a:pPr>
             <a:r>
-              <a:t>[입력]</a:t>
+              <a:t>정상 동작 검증 (Pass)</a:t>
             </a:r>
           </a:p>
         </p:txBody>
@@ -9645,7 +9282,7 @@
               </a:defRPr>
             </a:pPr>
             <a:r>
-              <a:t>[입력]</a:t>
+              <a:t>정상 동작 검증 (Pass)</a:t>
             </a:r>
           </a:p>
         </p:txBody>
@@ -9725,7 +9362,7 @@
               </a:defRPr>
             </a:pPr>
             <a:r>
-              <a:t>[입력]</a:t>
+              <a:t>정상 동작 검증 (Pass)</a:t>
             </a:r>
           </a:p>
         </p:txBody>
@@ -9805,7 +9442,7 @@
               </a:defRPr>
             </a:pPr>
             <a:r>
-              <a:t>[입력]</a:t>
+              <a:t>정상 동작 검증 (Pass)</a:t>
             </a:r>
           </a:p>
         </p:txBody>
@@ -9912,48 +9549,15 @@
           </a:bodyPr>
           <a:lstStyle/>
           <a:p>
-            <a:r>
-              <a:t>성과 지표</a:t>
-            </a:r>
-          </a:p>
-          <a:p>
+            <a:pPr algn="l">
+              <a:defRPr sz="1100" b="0">
+                <a:solidFill>
+                  <a:srgbClr val="333333"/>
+                </a:solidFill>
+              </a:defRPr>
+            </a:pPr>
             <a:r>
               <a:t>정확도</a:t>
-            </a:r>
-          </a:p>
-          <a:p>
-            <a:r>
-              <a:t>100%</a:t>
-            </a:r>
-          </a:p>
-          <a:p>
-            <a:r>
-              <a:t>처리 속도</a:t>
-            </a:r>
-          </a:p>
-          <a:p>
-            <a:r>
-              <a:t>&lt;1ms</a:t>
-            </a:r>
-          </a:p>
-          <a:p>
-            <a:r>
-              <a:t>테스트 통과율</a:t>
-            </a:r>
-          </a:p>
-          <a:p>
-            <a:r>
-              <a:t>100%</a:t>
-            </a:r>
-          </a:p>
-          <a:p>
-            <a:r>
-              <a:t>커버리지</a:t>
-            </a:r>
-          </a:p>
-          <a:p>
-            <a:r>
-              <a:t>100%</a:t>
             </a:r>
           </a:p>
         </p:txBody>
@@ -9988,7 +9592,7 @@
               </a:defRPr>
             </a:pPr>
             <a:r>
-              <a:t>[__]%</a:t>
+              <a:t>100%</a:t>
             </a:r>
           </a:p>
         </p:txBody>
@@ -10058,7 +9662,7 @@
               </a:defRPr>
             </a:pPr>
             <a:r>
-              <a:t>[__]ms</a:t>
+              <a:t>&lt;1ms</a:t>
             </a:r>
           </a:p>
         </p:txBody>
@@ -10128,7 +9732,7 @@
               </a:defRPr>
             </a:pPr>
             <a:r>
-              <a:t>[__]%</a:t>
+              <a:t>100%</a:t>
             </a:r>
           </a:p>
         </p:txBody>
@@ -10198,7 +9802,7 @@
               </a:defRPr>
             </a:pPr>
             <a:r>
-              <a:t>[__]%</a:t>
+              <a:t>100%</a:t>
             </a:r>
           </a:p>
         </p:txBody>
@@ -10444,23 +10048,15 @@
           </a:bodyPr>
           <a:lstStyle/>
           <a:p>
+            <a:pPr algn="l">
+              <a:defRPr sz="1600" b="1">
+                <a:solidFill>
+                  <a:srgbClr val="003366"/>
+                </a:solidFill>
+              </a:defRPr>
+            </a:pPr>
             <a:r>
               <a:t>기술적 학습</a:t>
-            </a:r>
-          </a:p>
-          <a:p>
-            <a:r>
-              <a:t>• ISO 26262 기반 요구사항 도출 및 시스템 설계 방법론 체득</a:t>
-            </a:r>
-          </a:p>
-          <a:p>
-            <a:r>
-              <a:t>• MISRA C 코딩 가이드라인 실무 적용</a:t>
-            </a:r>
-          </a:p>
-          <a:p>
-            <a:r>
-              <a:t>• Cppcheck 및 GTest를 활용한 엄격한 품질보증 파이프라인</a:t>
             </a:r>
           </a:p>
         </p:txBody>
@@ -10495,17 +10091,7 @@
               </a:defRPr>
             </a:pPr>
             <a:r>
-              <a:t>• [학습 내용 1]</a:t>
-            </a:r>
-            <a:br/>
-            <a:br/>
-            <a:r>
-              <a:t>• [학습 내용 2]</a:t>
-            </a:r>
-            <a:br/>
-            <a:br/>
-            <a:r>
-              <a:t>• [학습 내용 3]</a:t>
+              <a:t>ISO 26262/ASPICE 기능안전 기반 요구사항(SRS) 및 시스템 구조(SwDD) 설계 체화</a:t>
             </a:r>
           </a:p>
         </p:txBody>
@@ -10577,18 +10163,15 @@
           </a:bodyPr>
           <a:lstStyle/>
           <a:p>
+            <a:pPr algn="l">
+              <a:defRPr sz="1600" b="1">
+                <a:solidFill>
+                  <a:srgbClr val="FF6A00"/>
+                </a:solidFill>
+              </a:defRPr>
+            </a:pPr>
             <a:r>
               <a:t>협업 &amp; 프로세스</a:t>
-            </a:r>
-          </a:p>
-          <a:p>
-            <a:r>
-              <a:t>• CI/CD 파이프라인(CMake + GTest)을 통한 테스트 자동화 구축</a:t>
-            </a:r>
-          </a:p>
-          <a:p>
-            <a:r>
-              <a:t>• GitHub Policy 및 커밋 컨벤션 준수 중요성</a:t>
             </a:r>
           </a:p>
         </p:txBody>
@@ -10623,17 +10206,7 @@
               </a:defRPr>
             </a:pPr>
             <a:r>
-              <a:t>• [학습 내용 1]</a:t>
-            </a:r>
-            <a:br/>
-            <a:br/>
-            <a:r>
-              <a:t>• [학습 내용 2]</a:t>
-            </a:r>
-            <a:br/>
-            <a:br/>
-            <a:r>
-              <a:t>• [학습 내용 3]</a:t>
+              <a:t>ISO 26262/ASPICE 기능안전 기반 요구사항(SRS) 및 시스템 구조(SwDD) 설계 체화</a:t>
             </a:r>
           </a:p>
         </p:txBody>
@@ -10705,28 +10278,15 @@
           </a:bodyPr>
           <a:lstStyle/>
           <a:p>
+            <a:pPr algn="l">
+              <a:defRPr sz="1600" b="1">
+                <a:solidFill>
+                  <a:srgbClr val="B4783C"/>
+                </a:solidFill>
+              </a:defRPr>
+            </a:pPr>
             <a:r>
               <a:t>도전 과제 &amp; 해결 과정</a:t>
-            </a:r>
-          </a:p>
-          <a:p>
-            <a:r>
-              <a:t>[도전 과제]</a:t>
-            </a:r>
-          </a:p>
-          <a:p>
-            <a:r>
-              <a:t>다양한 센서 이벤트 및 예외 상황 엣지케이스 테스트 난이도</a:t>
-            </a:r>
-          </a:p>
-          <a:p>
-            <a:r>
-              <a:t>[해결 방법]</a:t>
-            </a:r>
-          </a:p>
-          <a:p>
-            <a:r>
-              <a:t>TDD 방법론 도입 및 Failure Mode (FMEA/HARA) 사전 정의 후 분기 모의</a:t>
             </a:r>
           </a:p>
         </p:txBody>
@@ -10753,28 +10313,15 @@
           </a:bodyPr>
           <a:lstStyle/>
           <a:p>
-            <a:r>
-              <a:t>도전 과제 &amp; 해결 과정</a:t>
-            </a:r>
-          </a:p>
-          <a:p>
-            <a:r>
-              <a:t>[도전 과제]</a:t>
-            </a:r>
-          </a:p>
-          <a:p>
-            <a:r>
-              <a:t>다양한 센서 이벤트 및 예외 상황 엣지케이스 테스트 난이도</a:t>
-            </a:r>
-          </a:p>
-          <a:p>
-            <a:r>
-              <a:t>[해결 방법]</a:t>
-            </a:r>
-          </a:p>
-          <a:p>
-            <a:r>
-              <a:t>TDD 방법론 도입 및 Failure Mode (FMEA/HARA) 사전 정의 후 분기 모의</a:t>
+            <a:pPr algn="l">
+              <a:defRPr sz="1200" b="1">
+                <a:solidFill>
+                  <a:srgbClr val="333333"/>
+                </a:solidFill>
+              </a:defRPr>
+            </a:pPr>
+            <a:r>
+              <a:t>도전 과제</a:t>
             </a:r>
           </a:p>
         </p:txBody>
@@ -10809,11 +10356,7 @@
               </a:defRPr>
             </a:pPr>
             <a:r>
-              <a:t>• [어려웠던 점 1]</a:t>
-            </a:r>
-            <a:br/>
-            <a:r>
-              <a:t>• [어려웠던 점 2]</a:t>
+              <a:t>복합 센서 예외 조건 처리 로직의 복잡성 증가 및 Fault 발생 시나리오 정리 애로</a:t>
             </a:r>
           </a:p>
         </p:txBody>
@@ -10883,11 +10426,7 @@
               </a:defRPr>
             </a:pPr>
             <a:r>
-              <a:t>• [해결 방법 1]</a:t>
-            </a:r>
-            <a:br/>
-            <a:r>
-              <a:t>• [해결 방법 2]</a:t>
+              <a:t>Fault Injection 테스트 케이스와 Fail-Safe 시나리오(Decision Table) 구체화 적용</a:t>
             </a:r>
           </a:p>
         </p:txBody>
@@ -11219,23 +10758,15 @@
           </a:bodyPr>
           <a:lstStyle/>
           <a:p>
+            <a:pPr algn="ctr">
+              <a:defRPr sz="1400" b="1">
+                <a:solidFill>
+                  <a:srgbClr val="003366"/>
+                </a:solidFill>
+              </a:defRPr>
+            </a:pPr>
             <a:r>
               <a:t>1단계</a:t>
-            </a:r>
-          </a:p>
-          <a:p>
-            <a:r>
-              <a:t>[통신 연동 강화]</a:t>
-            </a:r>
-          </a:p>
-          <a:p>
-            <a:r>
-              <a:t>• CAN(차량 내 네트워크) 통신 레이어 모의 통합 반영</a:t>
-            </a:r>
-          </a:p>
-          <a:p>
-            <a:r>
-              <a:t>• 다양한 ECU 신호 통합 시뮬레이션</a:t>
             </a:r>
           </a:p>
         </p:txBody>
@@ -11270,7 +10801,7 @@
               </a:defRPr>
             </a:pPr>
             <a:r>
-              <a:t>[단기 개선]</a:t>
+              <a:t>CAN 통신 프로토콜 통합 제어</a:t>
             </a:r>
           </a:p>
         </p:txBody>
@@ -11305,11 +10836,7 @@
               </a:defRPr>
             </a:pPr>
             <a:r>
-              <a:t>• 상세 계획</a:t>
-            </a:r>
-            <a:br/>
-            <a:r>
-              <a:t>• 상세 계획</a:t>
+              <a:t>제어기 로직 고도화 적용</a:t>
             </a:r>
           </a:p>
         </p:txBody>
@@ -11379,23 +10906,15 @@
           </a:bodyPr>
           <a:lstStyle/>
           <a:p>
+            <a:pPr algn="ctr">
+              <a:defRPr sz="1400" b="1">
+                <a:solidFill>
+                  <a:srgbClr val="003366"/>
+                </a:solidFill>
+              </a:defRPr>
+            </a:pPr>
             <a:r>
               <a:t>2단계</a:t>
-            </a:r>
-          </a:p>
-          <a:p>
-            <a:r>
-              <a:t>[하드웨어 포팅]</a:t>
-            </a:r>
-          </a:p>
-          <a:p>
-            <a:r>
-              <a:t>• 실제 모터 제어(Actuator) 보드 포팅 및 검증</a:t>
-            </a:r>
-          </a:p>
-          <a:p>
-            <a:r>
-              <a:t>• 실시간 운영체제(RTOS) 환경 최적화</a:t>
             </a:r>
           </a:p>
         </p:txBody>
@@ -11430,7 +10949,7 @@
               </a:defRPr>
             </a:pPr>
             <a:r>
-              <a:t>[기능 확장]</a:t>
+              <a:t>동적 주행 센서 (라이다/레이더) 시그널 결합</a:t>
             </a:r>
           </a:p>
         </p:txBody>
@@ -11465,11 +10984,7 @@
               </a:defRPr>
             </a:pPr>
             <a:r>
-              <a:t>• 상세 계획</a:t>
-            </a:r>
-            <a:br/>
-            <a:r>
-              <a:t>• 상세 계획</a:t>
+              <a:t>제어기 로직 고도화 적용</a:t>
             </a:r>
           </a:p>
         </p:txBody>
@@ -11539,23 +11054,15 @@
           </a:bodyPr>
           <a:lstStyle/>
           <a:p>
+            <a:pPr algn="ctr">
+              <a:defRPr sz="1400" b="1">
+                <a:solidFill>
+                  <a:srgbClr val="003366"/>
+                </a:solidFill>
+              </a:defRPr>
+            </a:pPr>
             <a:r>
               <a:t>3단계</a:t>
-            </a:r>
-          </a:p>
-          <a:p>
-            <a:r>
-              <a:t>[실용화]</a:t>
-            </a:r>
-          </a:p>
-          <a:p>
-            <a:r>
-              <a:t>• 고도화된 타겟 환경 통합 플랫폼 시연</a:t>
-            </a:r>
-          </a:p>
-          <a:p>
-            <a:r>
-              <a:t>• 동적 분석 추가 도입을 통한 기능 안전 규격 확보 강화</a:t>
             </a:r>
           </a:p>
         </p:txBody>
@@ -11590,7 +11097,7 @@
               </a:defRPr>
             </a:pPr>
             <a:r>
-              <a:t>[실용화]</a:t>
+              <a:t>T-05 도어 제어 ECU 타겟 하드웨어 포팅</a:t>
             </a:r>
           </a:p>
         </p:txBody>
@@ -11625,11 +11132,7 @@
               </a:defRPr>
             </a:pPr>
             <a:r>
-              <a:t>• 상세 계획</a:t>
-            </a:r>
-            <a:br/>
-            <a:r>
-              <a:t>• 상세 계획</a:t>
+              <a:t>제어기 로직 고도화 적용</a:t>
             </a:r>
           </a:p>
         </p:txBody>
@@ -11701,18 +11204,15 @@
           </a:bodyPr>
           <a:lstStyle/>
           <a:p>
+            <a:pPr algn="l">
+              <a:defRPr sz="1600" b="1">
+                <a:solidFill>
+                  <a:srgbClr val="3C8C3C"/>
+                </a:solidFill>
+              </a:defRPr>
+            </a:pPr>
             <a:r>
               <a:t>실무 적용 가능성</a:t>
-            </a:r>
-          </a:p>
-          <a:p>
-            <a:r>
-              <a:t>• 현대모비스/협력사의 차세대 통합 차량 제어기 플랫폼</a:t>
-            </a:r>
-          </a:p>
-          <a:p>
-            <a:r>
-              <a:t>• 하차 안전 보조와 차일드 락 기능 간소화 및 통합 지능화 모듈 솔루션</a:t>
             </a:r>
           </a:p>
         </p:txBody>
@@ -11747,17 +11247,7 @@
               </a:defRPr>
             </a:pPr>
             <a:r>
-              <a:t>• [현대모비스/협력사 적용 가능 영역]</a:t>
-            </a:r>
-            <a:br/>
-            <a:br/>
-            <a:r>
-              <a:t>• [기대 효과]</a:t>
-            </a:r>
-            <a:br/>
-            <a:br/>
-            <a:r>
-              <a:t>• [필요 조건]</a:t>
+              <a:t>현대모비스 차세대 통합 하차 제어 시스템 모듈</a:t>
             </a:r>
           </a:p>
         </p:txBody>
@@ -11829,18 +11319,15 @@
           </a:bodyPr>
           <a:lstStyle/>
           <a:p>
+            <a:pPr algn="l">
+              <a:defRPr sz="1600" b="1">
+                <a:solidFill>
+                  <a:srgbClr val="003366"/>
+                </a:solidFill>
+              </a:defRPr>
+            </a:pPr>
             <a:r>
               <a:t>추가 개발 아이디어</a:t>
-            </a:r>
-          </a:p>
-          <a:p>
-            <a:r>
-              <a:t>• 모바일 앱 제어 API 제공 (블루투스 연동)</a:t>
-            </a:r>
-          </a:p>
-          <a:p>
-            <a:r>
-              <a:t>• 레이더/라이다 기반 더욱 정밀한 후측방 접근 객체 분류</a:t>
             </a:r>
           </a:p>
         </p:txBody>
@@ -11875,17 +11362,7 @@
               </a:defRPr>
             </a:pPr>
             <a:r>
-              <a:t>• [아이디어 1]</a:t>
-            </a:r>
-            <a:br/>
-            <a:br/>
-            <a:r>
-              <a:t>• [아이디어 2]</a:t>
-            </a:r>
-            <a:br/>
-            <a:br/>
-            <a:r>
-              <a:t>• [아이디어 3]</a:t>
+              <a:t>BLE 기반 부모 스마트폰 앱 연동 강제 오버라이드 기능 추가</a:t>
             </a:r>
           </a:p>
         </p:txBody>

</xml_diff>